<commit_message>
[go-slide-creator-y3gv] mktemplate(warm-coral): full-width top bar
Give warm-coral a signature top bar so the theme reads distinct from
midnight-blue and forest-green. The bar is emitted from the slide
master, derives its height from the master title placeholder's y-offset
(365125 EMU) minus a 1pt gap, and spans the full 12192000 EMU slide
width. Every layout's title sits at or below the master offset, so no
overlap is possible on any of the 7 mandatory layouts.

* Add warm-coral case to chromeShapes() routing to new warmCoralChrome().
* warmCoralChrome() emits a single accent1-filled rectangle at (0,0)
  with cx=12192000 cy=352425.
* Regenerate templates/warm-coral.pptx. template-check now PASSes with
  zero WARN/FAIL, so drop its entry from
  internal/template/testdata/conformance_allowlist.json.
</commit_message>
<xml_diff>
--- a/templates/warm-coral.pptx
+++ b/templates/warm-coral.pptx
@@ -474,7 +474,7 @@
       </p:sp>
       <p:sp>
         <p:nvSpPr>
-          <p:cNvPr id="3" name="body"/>
+          <p:cNvPr id="3" name="Section Number"/>
           <p:cNvSpPr>
             <a:spLocks noGrp="1"/>
           </p:cNvSpPr>
@@ -491,9 +491,13 @@
         <p:txBody>
           <a:bodyPr/>
           <a:lstStyle>
-            <a:lvl1pPr marL="11113" indent="-11113">
+            <a:lvl1pPr marL="11113" indent="-11113" algn="r">
               <a:buNone/>
-              <a:defRPr sz="9600"/>
+              <a:defRPr sz="13600">
+                <a:solidFill>
+                  <a:schemeClr val="accent1"/>
+                </a:solidFill>
+              </a:defRPr>
             </a:lvl1pPr>
           </a:lstStyle>
           <a:p>
@@ -906,14 +910,14 @@
       </p:sp>
       <p:sp>
         <p:nvSpPr>
-          <p:cNvPr id="7" name="Accent Bar"/>
+          <p:cNvPr id="7" name="Top Bar"/>
           <p:cNvSpPr/>
           <p:nvPr/>
         </p:nvSpPr>
         <p:spPr>
           <a:xfrm>
             <a:off x="0" y="0"/>
-            <a:ext cx="228600" cy="6858000"/>
+            <a:ext cx="12192000" cy="352425"/>
           </a:xfrm>
           <a:prstGeom prst="rect">
             <a:avLst/>

</xml_diff>